<commit_message>
update the test of example rag usage: keywords extraction, chinese and english responsing
</commit_message>
<xml_diff>
--- a/Project/目前功能流程.pptx
+++ b/Project/目前功能流程.pptx
@@ -5,8 +5,8 @@
     <p:sldMasterId id="2147483648" r:id="rId1"/>
   </p:sldMasterIdLst>
   <p:sldIdLst>
-    <p:sldId id="256" r:id="rId2"/>
-    <p:sldId id="257" r:id="rId3"/>
+    <p:sldId id="257" r:id="rId2"/>
+    <p:sldId id="256" r:id="rId3"/>
   </p:sldIdLst>
   <p:sldSz cx="12192000" cy="6858000"/>
   <p:notesSz cx="6858000" cy="9144000"/>
@@ -105,6 +105,11 @@
       </a:defRPr>
     </a:lvl9pPr>
   </p:defaultTextStyle>
+  <p:extLst>
+    <p:ext uri="{EFAFB233-063F-42B5-8137-9DF3F51BA10A}">
+      <p15:sldGuideLst xmlns:p15="http://schemas.microsoft.com/office/powerpoint/2012/main"/>
+    </p:ext>
+  </p:extLst>
 </p:presentation>
 </file>
 
@@ -255,7 +260,7 @@
           <a:p>
             <a:fld id="{066F87F1-20BE-42E4-A1AE-CA751293DE56}" type="datetimeFigureOut">
               <a:rPr lang="en-US" smtClean="0"/>
-              <a:t>7/10/2025</a:t>
+              <a:t>7/11/2025</a:t>
             </a:fld>
             <a:endParaRPr lang="en-US"/>
           </a:p>
@@ -453,7 +458,7 @@
           <a:p>
             <a:fld id="{066F87F1-20BE-42E4-A1AE-CA751293DE56}" type="datetimeFigureOut">
               <a:rPr lang="en-US" smtClean="0"/>
-              <a:t>7/10/2025</a:t>
+              <a:t>7/11/2025</a:t>
             </a:fld>
             <a:endParaRPr lang="en-US"/>
           </a:p>
@@ -661,7 +666,7 @@
           <a:p>
             <a:fld id="{066F87F1-20BE-42E4-A1AE-CA751293DE56}" type="datetimeFigureOut">
               <a:rPr lang="en-US" smtClean="0"/>
-              <a:t>7/10/2025</a:t>
+              <a:t>7/11/2025</a:t>
             </a:fld>
             <a:endParaRPr lang="en-US"/>
           </a:p>
@@ -859,7 +864,7 @@
           <a:p>
             <a:fld id="{066F87F1-20BE-42E4-A1AE-CA751293DE56}" type="datetimeFigureOut">
               <a:rPr lang="en-US" smtClean="0"/>
-              <a:t>7/10/2025</a:t>
+              <a:t>7/11/2025</a:t>
             </a:fld>
             <a:endParaRPr lang="en-US"/>
           </a:p>
@@ -1134,7 +1139,7 @@
           <a:p>
             <a:fld id="{066F87F1-20BE-42E4-A1AE-CA751293DE56}" type="datetimeFigureOut">
               <a:rPr lang="en-US" smtClean="0"/>
-              <a:t>7/10/2025</a:t>
+              <a:t>7/11/2025</a:t>
             </a:fld>
             <a:endParaRPr lang="en-US"/>
           </a:p>
@@ -1399,7 +1404,7 @@
           <a:p>
             <a:fld id="{066F87F1-20BE-42E4-A1AE-CA751293DE56}" type="datetimeFigureOut">
               <a:rPr lang="en-US" smtClean="0"/>
-              <a:t>7/10/2025</a:t>
+              <a:t>7/11/2025</a:t>
             </a:fld>
             <a:endParaRPr lang="en-US"/>
           </a:p>
@@ -1811,7 +1816,7 @@
           <a:p>
             <a:fld id="{066F87F1-20BE-42E4-A1AE-CA751293DE56}" type="datetimeFigureOut">
               <a:rPr lang="en-US" smtClean="0"/>
-              <a:t>7/10/2025</a:t>
+              <a:t>7/11/2025</a:t>
             </a:fld>
             <a:endParaRPr lang="en-US"/>
           </a:p>
@@ -1952,7 +1957,7 @@
           <a:p>
             <a:fld id="{066F87F1-20BE-42E4-A1AE-CA751293DE56}" type="datetimeFigureOut">
               <a:rPr lang="en-US" smtClean="0"/>
-              <a:t>7/10/2025</a:t>
+              <a:t>7/11/2025</a:t>
             </a:fld>
             <a:endParaRPr lang="en-US"/>
           </a:p>
@@ -2065,7 +2070,7 @@
           <a:p>
             <a:fld id="{066F87F1-20BE-42E4-A1AE-CA751293DE56}" type="datetimeFigureOut">
               <a:rPr lang="en-US" smtClean="0"/>
-              <a:t>7/10/2025</a:t>
+              <a:t>7/11/2025</a:t>
             </a:fld>
             <a:endParaRPr lang="en-US"/>
           </a:p>
@@ -2376,7 +2381,7 @@
           <a:p>
             <a:fld id="{066F87F1-20BE-42E4-A1AE-CA751293DE56}" type="datetimeFigureOut">
               <a:rPr lang="en-US" smtClean="0"/>
-              <a:t>7/10/2025</a:t>
+              <a:t>7/11/2025</a:t>
             </a:fld>
             <a:endParaRPr lang="en-US"/>
           </a:p>
@@ -2664,7 +2669,7 @@
           <a:p>
             <a:fld id="{066F87F1-20BE-42E4-A1AE-CA751293DE56}" type="datetimeFigureOut">
               <a:rPr lang="en-US" smtClean="0"/>
-              <a:t>7/10/2025</a:t>
+              <a:t>7/11/2025</a:t>
             </a:fld>
             <a:endParaRPr lang="en-US"/>
           </a:p>
@@ -2905,7 +2910,7 @@
           <a:p>
             <a:fld id="{066F87F1-20BE-42E4-A1AE-CA751293DE56}" type="datetimeFigureOut">
               <a:rPr lang="en-US" smtClean="0"/>
-              <a:t>7/10/2025</a:t>
+              <a:t>7/11/2025</a:t>
             </a:fld>
             <a:endParaRPr lang="en-US"/>
           </a:p>
@@ -3310,7 +3315,13 @@
   <p:cSld>
     <p:spTree>
       <p:nvGrpSpPr>
-        <p:cNvPr id="1" name=""/>
+        <p:cNvPr id="1" name="">
+          <a:extLst>
+            <a:ext uri="{FF2B5EF4-FFF2-40B4-BE49-F238E27FC236}">
+              <a16:creationId xmlns:a16="http://schemas.microsoft.com/office/drawing/2014/main" id="{A2CAD655-24F0-15EF-2429-E46C23BF2BC4}"/>
+            </a:ext>
+          </a:extLst>
+        </p:cNvPr>
         <p:cNvGrpSpPr/>
         <p:nvPr/>
       </p:nvGrpSpPr>
@@ -3327,7 +3338,7 @@
           <p:cNvPr id="16" name="Rectangle 15">
             <a:extLst>
               <a:ext uri="{FF2B5EF4-FFF2-40B4-BE49-F238E27FC236}">
-                <a16:creationId xmlns:a16="http://schemas.microsoft.com/office/drawing/2014/main" id="{17619719-04BB-0304-C0A4-A0BBC1BBC586}"/>
+                <a16:creationId xmlns:a16="http://schemas.microsoft.com/office/drawing/2014/main" id="{B785A9BB-D69A-63EE-E596-E159C542D712}"/>
               </a:ext>
             </a:extLst>
           </p:cNvPr>
@@ -3366,7 +3377,7 @@
             <a:pPr algn="ctr"/>
             <a:r>
               <a:rPr lang="zh-CN" altLang="en-US" dirty="0"/>
-              <a:t>用户查询输入</a:t>
+              <a:t>扫描文件夹</a:t>
             </a:r>
             <a:endParaRPr lang="en-US" dirty="0"/>
           </a:p>
@@ -3377,7 +3388,7 @@
           <p:cNvPr id="19" name="Rectangle 18">
             <a:extLst>
               <a:ext uri="{FF2B5EF4-FFF2-40B4-BE49-F238E27FC236}">
-                <a16:creationId xmlns:a16="http://schemas.microsoft.com/office/drawing/2014/main" id="{5048C773-65D6-CB69-2FFF-0DA83539A5EB}"/>
+                <a16:creationId xmlns:a16="http://schemas.microsoft.com/office/drawing/2014/main" id="{554D3032-DE51-CF6C-2CD1-EC44502BF3BC}"/>
               </a:ext>
             </a:extLst>
           </p:cNvPr>
@@ -3416,7 +3427,11 @@
             <a:pPr algn="ctr"/>
             <a:r>
               <a:rPr lang="zh-CN" altLang="en-US" dirty="0"/>
-              <a:t>查询理解（抽取关键词）</a:t>
+              <a:t>更新</a:t>
+            </a:r>
+            <a:r>
+              <a:rPr lang="en-US" altLang="zh-CN" dirty="0"/>
+              <a:t>PDF/TXT</a:t>
             </a:r>
             <a:endParaRPr lang="en-US" dirty="0"/>
           </a:p>
@@ -3427,7 +3442,7 @@
           <p:cNvPr id="20" name="Rectangle 19">
             <a:extLst>
               <a:ext uri="{FF2B5EF4-FFF2-40B4-BE49-F238E27FC236}">
-                <a16:creationId xmlns:a16="http://schemas.microsoft.com/office/drawing/2014/main" id="{CED19112-6537-EB71-AA7E-D1BC3C8E7FBB}"/>
+                <a16:creationId xmlns:a16="http://schemas.microsoft.com/office/drawing/2014/main" id="{5F825F44-B671-DCB8-6493-E0889A8CA17A}"/>
               </a:ext>
             </a:extLst>
           </p:cNvPr>
@@ -3465,12 +3480,8 @@
           <a:p>
             <a:pPr algn="ctr"/>
             <a:r>
-              <a:rPr lang="en-US" altLang="zh-CN" dirty="0"/>
-              <a:t>Chroma</a:t>
-            </a:r>
-            <a:r>
               <a:rPr lang="zh-CN" altLang="en-US" dirty="0"/>
-              <a:t>向量搜索</a:t>
+              <a:t>文本分块</a:t>
             </a:r>
             <a:endParaRPr lang="en-US" dirty="0"/>
           </a:p>
@@ -3481,7 +3492,7 @@
           <p:cNvPr id="21" name="Rectangle 20">
             <a:extLst>
               <a:ext uri="{FF2B5EF4-FFF2-40B4-BE49-F238E27FC236}">
-                <a16:creationId xmlns:a16="http://schemas.microsoft.com/office/drawing/2014/main" id="{94AC3347-0B54-436B-50B3-8588E8320F1E}"/>
+                <a16:creationId xmlns:a16="http://schemas.microsoft.com/office/drawing/2014/main" id="{EBBF3ED3-35C7-8AD6-0A6D-3E61E577B339}"/>
               </a:ext>
             </a:extLst>
           </p:cNvPr>
@@ -3520,7 +3531,15 @@
             <a:pPr algn="ctr"/>
             <a:r>
               <a:rPr lang="zh-CN" altLang="en-US" dirty="0"/>
-              <a:t>返回结果</a:t>
+              <a:t>使用</a:t>
+            </a:r>
+            <a:r>
+              <a:rPr lang="en-US" altLang="zh-CN" dirty="0" err="1"/>
+              <a:t>json</a:t>
+            </a:r>
+            <a:r>
+              <a:rPr lang="zh-CN" altLang="en-US" dirty="0"/>
+              <a:t>记录文件库信息</a:t>
             </a:r>
             <a:endParaRPr lang="en-US" dirty="0"/>
           </a:p>
@@ -3531,7 +3550,7 @@
           <p:cNvPr id="22" name="Rectangle 21">
             <a:extLst>
               <a:ext uri="{FF2B5EF4-FFF2-40B4-BE49-F238E27FC236}">
-                <a16:creationId xmlns:a16="http://schemas.microsoft.com/office/drawing/2014/main" id="{442AA2D3-5567-8EBC-17FC-57D9BC8EEFEC}"/>
+                <a16:creationId xmlns:a16="http://schemas.microsoft.com/office/drawing/2014/main" id="{E39AF769-FAF4-6D97-5515-D3C340D15865}"/>
               </a:ext>
             </a:extLst>
           </p:cNvPr>
@@ -3569,12 +3588,12 @@
           <a:p>
             <a:pPr algn="ctr"/>
             <a:r>
+              <a:rPr lang="zh-CN" altLang="en-US" dirty="0"/>
+              <a:t>存入</a:t>
+            </a:r>
+            <a:r>
               <a:rPr lang="en-US" altLang="zh-CN" dirty="0"/>
-              <a:t>LLM</a:t>
-            </a:r>
-            <a:r>
-              <a:rPr lang="zh-CN" altLang="en-US" dirty="0"/>
-              <a:t>生成回答</a:t>
+              <a:t>chroma</a:t>
             </a:r>
             <a:endParaRPr lang="en-US" dirty="0"/>
           </a:p>
@@ -3585,7 +3604,7 @@
           <p:cNvPr id="23" name="Rectangle 22">
             <a:extLst>
               <a:ext uri="{FF2B5EF4-FFF2-40B4-BE49-F238E27FC236}">
-                <a16:creationId xmlns:a16="http://schemas.microsoft.com/office/drawing/2014/main" id="{C6EECA45-1625-21B9-4A28-BD3C6FA375C4}"/>
+                <a16:creationId xmlns:a16="http://schemas.microsoft.com/office/drawing/2014/main" id="{50674E68-C038-53B0-ABBF-DF27288CC5A5}"/>
               </a:ext>
             </a:extLst>
           </p:cNvPr>
@@ -3623,12 +3642,8 @@
           <a:p>
             <a:pPr algn="ctr"/>
             <a:r>
-              <a:rPr lang="en-US" altLang="zh-CN" dirty="0"/>
-              <a:t>LLM</a:t>
-            </a:r>
-            <a:r>
               <a:rPr lang="zh-CN" altLang="en-US" dirty="0"/>
-              <a:t>重排序</a:t>
+              <a:t>嵌入向量</a:t>
             </a:r>
             <a:endParaRPr lang="en-US" dirty="0"/>
           </a:p>
@@ -3639,7 +3654,7 @@
           <p:cNvPr id="25" name="Straight Arrow Connector 24">
             <a:extLst>
               <a:ext uri="{FF2B5EF4-FFF2-40B4-BE49-F238E27FC236}">
-                <a16:creationId xmlns:a16="http://schemas.microsoft.com/office/drawing/2014/main" id="{69A0F789-2D1C-67C4-AFDA-9B4F7B53DC11}"/>
+                <a16:creationId xmlns:a16="http://schemas.microsoft.com/office/drawing/2014/main" id="{7A4D7015-D72A-FAE5-3575-3BC32A686749}"/>
               </a:ext>
             </a:extLst>
           </p:cNvPr>
@@ -3681,7 +3696,7 @@
           <p:cNvPr id="27" name="Straight Arrow Connector 26">
             <a:extLst>
               <a:ext uri="{FF2B5EF4-FFF2-40B4-BE49-F238E27FC236}">
-                <a16:creationId xmlns:a16="http://schemas.microsoft.com/office/drawing/2014/main" id="{ED4408CB-7E1A-647B-05C2-92A860657912}"/>
+                <a16:creationId xmlns:a16="http://schemas.microsoft.com/office/drawing/2014/main" id="{BED6CC5A-7DE8-7D56-33ED-F22AA6C87B76}"/>
               </a:ext>
             </a:extLst>
           </p:cNvPr>
@@ -3720,7 +3735,7 @@
           <p:cNvPr id="29" name="Straight Arrow Connector 28">
             <a:extLst>
               <a:ext uri="{FF2B5EF4-FFF2-40B4-BE49-F238E27FC236}">
-                <a16:creationId xmlns:a16="http://schemas.microsoft.com/office/drawing/2014/main" id="{EF1C88DA-ECEE-6C5C-ADA5-C04F4EFA50F1}"/>
+                <a16:creationId xmlns:a16="http://schemas.microsoft.com/office/drawing/2014/main" id="{ED399563-19A0-5B33-CF98-F81CDF3D2F5C}"/>
               </a:ext>
             </a:extLst>
           </p:cNvPr>
@@ -3762,7 +3777,7 @@
           <p:cNvPr id="30" name="Straight Arrow Connector 29">
             <a:extLst>
               <a:ext uri="{FF2B5EF4-FFF2-40B4-BE49-F238E27FC236}">
-                <a16:creationId xmlns:a16="http://schemas.microsoft.com/office/drawing/2014/main" id="{CDE9D74B-E8B2-06A1-6E16-667B0F5566E4}"/>
+                <a16:creationId xmlns:a16="http://schemas.microsoft.com/office/drawing/2014/main" id="{A7455010-39F1-7D6B-43EB-FA88B7461ED5}"/>
               </a:ext>
             </a:extLst>
           </p:cNvPr>
@@ -3804,7 +3819,7 @@
           <p:cNvPr id="35" name="Straight Arrow Connector 34">
             <a:extLst>
               <a:ext uri="{FF2B5EF4-FFF2-40B4-BE49-F238E27FC236}">
-                <a16:creationId xmlns:a16="http://schemas.microsoft.com/office/drawing/2014/main" id="{A2AA077B-D1B6-AEAF-91BD-DE5F58D448D7}"/>
+                <a16:creationId xmlns:a16="http://schemas.microsoft.com/office/drawing/2014/main" id="{ADB5176E-EE0B-75A4-791F-01198D276B2F}"/>
               </a:ext>
             </a:extLst>
           </p:cNvPr>
@@ -3843,7 +3858,7 @@
     </p:spTree>
     <p:extLst>
       <p:ext uri="{BB962C8B-B14F-4D97-AF65-F5344CB8AC3E}">
-        <p14:creationId xmlns:p14="http://schemas.microsoft.com/office/powerpoint/2010/main" val="4035808760"/>
+        <p14:creationId xmlns:p14="http://schemas.microsoft.com/office/powerpoint/2010/main" val="3358053125"/>
       </p:ext>
     </p:extLst>
   </p:cSld>
@@ -3858,13 +3873,7 @@
   <p:cSld>
     <p:spTree>
       <p:nvGrpSpPr>
-        <p:cNvPr id="1" name="">
-          <a:extLst>
-            <a:ext uri="{FF2B5EF4-FFF2-40B4-BE49-F238E27FC236}">
-              <a16:creationId xmlns:a16="http://schemas.microsoft.com/office/drawing/2014/main" id="{A2CAD655-24F0-15EF-2429-E46C23BF2BC4}"/>
-            </a:ext>
-          </a:extLst>
-        </p:cNvPr>
+        <p:cNvPr id="1" name=""/>
         <p:cNvGrpSpPr/>
         <p:nvPr/>
       </p:nvGrpSpPr>
@@ -3881,7 +3890,7 @@
           <p:cNvPr id="16" name="Rectangle 15">
             <a:extLst>
               <a:ext uri="{FF2B5EF4-FFF2-40B4-BE49-F238E27FC236}">
-                <a16:creationId xmlns:a16="http://schemas.microsoft.com/office/drawing/2014/main" id="{B785A9BB-D69A-63EE-E596-E159C542D712}"/>
+                <a16:creationId xmlns:a16="http://schemas.microsoft.com/office/drawing/2014/main" id="{17619719-04BB-0304-C0A4-A0BBC1BBC586}"/>
               </a:ext>
             </a:extLst>
           </p:cNvPr>
@@ -3920,7 +3929,7 @@
             <a:pPr algn="ctr"/>
             <a:r>
               <a:rPr lang="zh-CN" altLang="en-US" dirty="0"/>
-              <a:t>扫描文件夹</a:t>
+              <a:t>用户查询输入</a:t>
             </a:r>
             <a:endParaRPr lang="en-US" dirty="0"/>
           </a:p>
@@ -3931,7 +3940,7 @@
           <p:cNvPr id="19" name="Rectangle 18">
             <a:extLst>
               <a:ext uri="{FF2B5EF4-FFF2-40B4-BE49-F238E27FC236}">
-                <a16:creationId xmlns:a16="http://schemas.microsoft.com/office/drawing/2014/main" id="{554D3032-DE51-CF6C-2CD1-EC44502BF3BC}"/>
+                <a16:creationId xmlns:a16="http://schemas.microsoft.com/office/drawing/2014/main" id="{5048C773-65D6-CB69-2FFF-0DA83539A5EB}"/>
               </a:ext>
             </a:extLst>
           </p:cNvPr>
@@ -3970,11 +3979,7 @@
             <a:pPr algn="ctr"/>
             <a:r>
               <a:rPr lang="zh-CN" altLang="en-US" dirty="0"/>
-              <a:t>更新</a:t>
-            </a:r>
-            <a:r>
-              <a:rPr lang="en-US" altLang="zh-CN" dirty="0"/>
-              <a:t>PDF/TXT</a:t>
+              <a:t>查询理解（抽取关键词）</a:t>
             </a:r>
             <a:endParaRPr lang="en-US" dirty="0"/>
           </a:p>
@@ -3985,7 +3990,7 @@
           <p:cNvPr id="20" name="Rectangle 19">
             <a:extLst>
               <a:ext uri="{FF2B5EF4-FFF2-40B4-BE49-F238E27FC236}">
-                <a16:creationId xmlns:a16="http://schemas.microsoft.com/office/drawing/2014/main" id="{5F825F44-B671-DCB8-6493-E0889A8CA17A}"/>
+                <a16:creationId xmlns:a16="http://schemas.microsoft.com/office/drawing/2014/main" id="{CED19112-6537-EB71-AA7E-D1BC3C8E7FBB}"/>
               </a:ext>
             </a:extLst>
           </p:cNvPr>
@@ -4023,8 +4028,12 @@
           <a:p>
             <a:pPr algn="ctr"/>
             <a:r>
+              <a:rPr lang="en-US" altLang="zh-CN" dirty="0"/>
+              <a:t>Chroma</a:t>
+            </a:r>
+            <a:r>
               <a:rPr lang="zh-CN" altLang="en-US" dirty="0"/>
-              <a:t>文本分块</a:t>
+              <a:t>向量搜索</a:t>
             </a:r>
             <a:endParaRPr lang="en-US" dirty="0"/>
           </a:p>
@@ -4035,7 +4044,7 @@
           <p:cNvPr id="21" name="Rectangle 20">
             <a:extLst>
               <a:ext uri="{FF2B5EF4-FFF2-40B4-BE49-F238E27FC236}">
-                <a16:creationId xmlns:a16="http://schemas.microsoft.com/office/drawing/2014/main" id="{EBBF3ED3-35C7-8AD6-0A6D-3E61E577B339}"/>
+                <a16:creationId xmlns:a16="http://schemas.microsoft.com/office/drawing/2014/main" id="{94AC3347-0B54-436B-50B3-8588E8320F1E}"/>
               </a:ext>
             </a:extLst>
           </p:cNvPr>
@@ -4074,15 +4083,7 @@
             <a:pPr algn="ctr"/>
             <a:r>
               <a:rPr lang="zh-CN" altLang="en-US" dirty="0"/>
-              <a:t>使用</a:t>
-            </a:r>
-            <a:r>
-              <a:rPr lang="en-US" altLang="zh-CN" dirty="0" err="1"/>
-              <a:t>json</a:t>
-            </a:r>
-            <a:r>
-              <a:rPr lang="zh-CN" altLang="en-US" dirty="0"/>
-              <a:t>记录文件库信息</a:t>
+              <a:t>返回结果</a:t>
             </a:r>
             <a:endParaRPr lang="en-US" dirty="0"/>
           </a:p>
@@ -4093,7 +4094,7 @@
           <p:cNvPr id="22" name="Rectangle 21">
             <a:extLst>
               <a:ext uri="{FF2B5EF4-FFF2-40B4-BE49-F238E27FC236}">
-                <a16:creationId xmlns:a16="http://schemas.microsoft.com/office/drawing/2014/main" id="{E39AF769-FAF4-6D97-5515-D3C340D15865}"/>
+                <a16:creationId xmlns:a16="http://schemas.microsoft.com/office/drawing/2014/main" id="{442AA2D3-5567-8EBC-17FC-57D9BC8EEFEC}"/>
               </a:ext>
             </a:extLst>
           </p:cNvPr>
@@ -4131,12 +4132,12 @@
           <a:p>
             <a:pPr algn="ctr"/>
             <a:r>
+              <a:rPr lang="en-US" altLang="zh-CN" dirty="0"/>
+              <a:t>LLM</a:t>
+            </a:r>
+            <a:r>
               <a:rPr lang="zh-CN" altLang="en-US" dirty="0"/>
-              <a:t>存入</a:t>
-            </a:r>
-            <a:r>
-              <a:rPr lang="en-US" altLang="zh-CN" dirty="0"/>
-              <a:t>chroma</a:t>
+              <a:t>生成回答</a:t>
             </a:r>
             <a:endParaRPr lang="en-US" dirty="0"/>
           </a:p>
@@ -4147,7 +4148,7 @@
           <p:cNvPr id="23" name="Rectangle 22">
             <a:extLst>
               <a:ext uri="{FF2B5EF4-FFF2-40B4-BE49-F238E27FC236}">
-                <a16:creationId xmlns:a16="http://schemas.microsoft.com/office/drawing/2014/main" id="{50674E68-C038-53B0-ABBF-DF27288CC5A5}"/>
+                <a16:creationId xmlns:a16="http://schemas.microsoft.com/office/drawing/2014/main" id="{C6EECA45-1625-21B9-4A28-BD3C6FA375C4}"/>
               </a:ext>
             </a:extLst>
           </p:cNvPr>
@@ -4185,8 +4186,12 @@
           <a:p>
             <a:pPr algn="ctr"/>
             <a:r>
+              <a:rPr lang="en-US" altLang="zh-CN" dirty="0"/>
+              <a:t>LLM</a:t>
+            </a:r>
+            <a:r>
               <a:rPr lang="zh-CN" altLang="en-US" dirty="0"/>
-              <a:t>嵌入向量</a:t>
+              <a:t>重排序</a:t>
             </a:r>
             <a:endParaRPr lang="en-US" dirty="0"/>
           </a:p>
@@ -4197,7 +4202,7 @@
           <p:cNvPr id="25" name="Straight Arrow Connector 24">
             <a:extLst>
               <a:ext uri="{FF2B5EF4-FFF2-40B4-BE49-F238E27FC236}">
-                <a16:creationId xmlns:a16="http://schemas.microsoft.com/office/drawing/2014/main" id="{7A4D7015-D72A-FAE5-3575-3BC32A686749}"/>
+                <a16:creationId xmlns:a16="http://schemas.microsoft.com/office/drawing/2014/main" id="{69A0F789-2D1C-67C4-AFDA-9B4F7B53DC11}"/>
               </a:ext>
             </a:extLst>
           </p:cNvPr>
@@ -4239,7 +4244,7 @@
           <p:cNvPr id="27" name="Straight Arrow Connector 26">
             <a:extLst>
               <a:ext uri="{FF2B5EF4-FFF2-40B4-BE49-F238E27FC236}">
-                <a16:creationId xmlns:a16="http://schemas.microsoft.com/office/drawing/2014/main" id="{BED6CC5A-7DE8-7D56-33ED-F22AA6C87B76}"/>
+                <a16:creationId xmlns:a16="http://schemas.microsoft.com/office/drawing/2014/main" id="{ED4408CB-7E1A-647B-05C2-92A860657912}"/>
               </a:ext>
             </a:extLst>
           </p:cNvPr>
@@ -4278,7 +4283,7 @@
           <p:cNvPr id="29" name="Straight Arrow Connector 28">
             <a:extLst>
               <a:ext uri="{FF2B5EF4-FFF2-40B4-BE49-F238E27FC236}">
-                <a16:creationId xmlns:a16="http://schemas.microsoft.com/office/drawing/2014/main" id="{ED399563-19A0-5B33-CF98-F81CDF3D2F5C}"/>
+                <a16:creationId xmlns:a16="http://schemas.microsoft.com/office/drawing/2014/main" id="{EF1C88DA-ECEE-6C5C-ADA5-C04F4EFA50F1}"/>
               </a:ext>
             </a:extLst>
           </p:cNvPr>
@@ -4320,7 +4325,7 @@
           <p:cNvPr id="30" name="Straight Arrow Connector 29">
             <a:extLst>
               <a:ext uri="{FF2B5EF4-FFF2-40B4-BE49-F238E27FC236}">
-                <a16:creationId xmlns:a16="http://schemas.microsoft.com/office/drawing/2014/main" id="{A7455010-39F1-7D6B-43EB-FA88B7461ED5}"/>
+                <a16:creationId xmlns:a16="http://schemas.microsoft.com/office/drawing/2014/main" id="{CDE9D74B-E8B2-06A1-6E16-667B0F5566E4}"/>
               </a:ext>
             </a:extLst>
           </p:cNvPr>
@@ -4362,7 +4367,7 @@
           <p:cNvPr id="35" name="Straight Arrow Connector 34">
             <a:extLst>
               <a:ext uri="{FF2B5EF4-FFF2-40B4-BE49-F238E27FC236}">
-                <a16:creationId xmlns:a16="http://schemas.microsoft.com/office/drawing/2014/main" id="{ADB5176E-EE0B-75A4-791F-01198D276B2F}"/>
+                <a16:creationId xmlns:a16="http://schemas.microsoft.com/office/drawing/2014/main" id="{A2AA077B-D1B6-AEAF-91BD-DE5F58D448D7}"/>
               </a:ext>
             </a:extLst>
           </p:cNvPr>
@@ -4401,7 +4406,7 @@
     </p:spTree>
     <p:extLst>
       <p:ext uri="{BB962C8B-B14F-4D97-AF65-F5344CB8AC3E}">
-        <p14:creationId xmlns:p14="http://schemas.microsoft.com/office/powerpoint/2010/main" val="3358053125"/>
+        <p14:creationId xmlns:p14="http://schemas.microsoft.com/office/powerpoint/2010/main" val="4035808760"/>
       </p:ext>
     </p:extLst>
   </p:cSld>

</xml_diff>